<commit_message>
docs(tutorial-1): add Trae IDE usage guide with screenshots
- Add comprehensive Trae IDE installation and configuration guide
- Include step-by-step instructions with 16 screenshots
- Cover extension installation, project configuration, and game design workflow
- Update Vibe Agentic Coding PPT presentation

Co-Authored-By: Claude Opus 4.6 <noreply@anthropic.com>
</commit_message>
<xml_diff>
--- a/Tutorial-0/Vibe_Agentic Coding 课程PPT.pptx
+++ b/Tutorial-0/Vibe_Agentic Coding 课程PPT.pptx
@@ -14886,6 +14886,18 @@
               <a:defRPr/>
             </a:pPr>
             <a:r>
+              <a:rPr lang="zh-CN" altLang="en-US" sz="2400" b="1" i="0" u="none" strike="noStrike">
+                <a:solidFill>
+                  <a:srgbClr val="000000"/>
+                </a:solidFill>
+                <a:latin typeface="Noto Sans SC" panose="020B0200000000000000" charset="-122"/>
+                <a:ea typeface="Noto Sans SC" panose="020B0200000000000000" charset="-122"/>
+                <a:cs typeface="Noto Sans SC" panose="020B0200000000000000" charset="-122"/>
+                <a:sym typeface="Noto Sans SC" panose="020B0200000000000000" charset="-122"/>
+              </a:rPr>
+              <a:t>课程</a:t>
+            </a:r>
+            <a:r>
               <a:rPr lang="en-US" sz="2400" b="1" i="0" u="none" strike="noStrike">
                 <a:solidFill>
                   <a:srgbClr val="000000"/>
@@ -14895,7 +14907,7 @@
                 <a:cs typeface="Noto Sans SC" panose="020B0200000000000000" charset="-122"/>
                 <a:sym typeface="Noto Sans SC" panose="020B0200000000000000" charset="-122"/>
               </a:rPr>
-              <a:t>AI编码工具选型（优先免费模型）</a:t>
+              <a:t>AI编码工具选型</a:t>
             </a:r>
             <a:endParaRPr lang="en-US" sz="1100"/>
           </a:p>
@@ -15700,14 +15712,14 @@
       </p:pic>
       <p:sp>
         <p:nvSpPr>
-          <p:cNvPr id="7" name="AutoShape 7"/>
+          <p:cNvPr id="8" name="AutoShape 8"/>
           <p:cNvSpPr/>
           <p:nvPr/>
         </p:nvSpPr>
         <p:spPr>
           <a:xfrm>
-            <a:off x="1778000" y="4508500"/>
-            <a:ext cx="8890000" cy="381000"/>
+            <a:off x="1778000" y="4635500"/>
+            <a:ext cx="9029700" cy="825500"/>
           </a:xfrm>
           <a:prstGeom prst="rect">
             <a:avLst/>
@@ -15730,45 +15742,27 @@
               <a:defRPr/>
             </a:pPr>
             <a:r>
-              <a:rPr lang="en-US" sz="1800" b="1" i="0" u="none" strike="noStrike">
+              <a:rPr lang="zh-CN" altLang="en-US" sz="1400" b="0" i="0" u="none" strike="noStrike">
                 <a:solidFill>
-                  <a:srgbClr val="EA580C"/>
+                  <a:srgbClr val="9A3412"/>
                 </a:solidFill>
                 <a:latin typeface="Noto Sans SC" panose="020B0200000000000000" charset="-122"/>
                 <a:ea typeface="Noto Sans SC" panose="020B0200000000000000" charset="-122"/>
                 <a:cs typeface="Noto Sans SC" panose="020B0200000000000000" charset="-122"/>
                 <a:sym typeface="Noto Sans SC" panose="020B0200000000000000" charset="-122"/>
               </a:rPr>
-              <a:t>入门推荐：Trae</a:t>
+              <a:t>原则：必须优先考虑免费模型，其实才是好用。</a:t>
             </a:r>
-            <a:endParaRPr lang="en-US" sz="1100"/>
+            <a:endParaRPr lang="zh-CN" altLang="en-US" sz="1400" b="0" i="0" u="none" strike="noStrike">
+              <a:solidFill>
+                <a:srgbClr val="9A3412"/>
+              </a:solidFill>
+              <a:latin typeface="Noto Sans SC" panose="020B0200000000000000" charset="-122"/>
+              <a:ea typeface="Noto Sans SC" panose="020B0200000000000000" charset="-122"/>
+              <a:cs typeface="Noto Sans SC" panose="020B0200000000000000" charset="-122"/>
+              <a:sym typeface="Noto Sans SC" panose="020B0200000000000000" charset="-122"/>
+            </a:endParaRPr>
           </a:p>
-        </p:txBody>
-      </p:sp>
-      <p:sp>
-        <p:nvSpPr>
-          <p:cNvPr id="8" name="AutoShape 8"/>
-          <p:cNvSpPr/>
-          <p:nvPr/>
-        </p:nvSpPr>
-        <p:spPr>
-          <a:xfrm>
-            <a:off x="1778000" y="4889500"/>
-            <a:ext cx="8890000" cy="508000"/>
-          </a:xfrm>
-          <a:prstGeom prst="rect">
-            <a:avLst/>
-          </a:prstGeom>
-          <a:noFill/>
-          <a:ln w="12700" cap="flat" cmpd="sng">
-            <a:noFill/>
-            <a:prstDash val="solid"/>
-            <a:round/>
-          </a:ln>
-        </p:spPr>
-        <p:txBody>
-          <a:bodyPr vert="horz" wrap="square" lIns="0" tIns="0" rIns="0" bIns="0" rtlCol="0" anchor="ctr" anchorCtr="0"/>
-          <a:lstStyle/>
           <a:p>
             <a:pPr indent="0" algn="l">
               <a:lnSpc>
@@ -15776,6 +15770,71 @@
               </a:lnSpc>
               <a:defRPr/>
             </a:pPr>
+            <a:r>
+              <a:rPr lang="zh-CN" altLang="en-US">
+                <a:solidFill>
+                  <a:srgbClr val="9A3412"/>
+                </a:solidFill>
+                <a:latin typeface="Noto Sans SC" panose="020B0200000000000000" charset="-122"/>
+                <a:ea typeface="Noto Sans SC" panose="020B0200000000000000" charset="-122"/>
+                <a:cs typeface="Noto Sans SC" panose="020B0200000000000000" charset="-122"/>
+                <a:sym typeface="Noto Sans SC" panose="020B0200000000000000" charset="-122"/>
+              </a:rPr>
+              <a:t>虽然还可以选</a:t>
+            </a:r>
+            <a:r>
+              <a:rPr lang="en-US" altLang="zh-CN">
+                <a:solidFill>
+                  <a:srgbClr val="9A3412"/>
+                </a:solidFill>
+                <a:latin typeface="Noto Sans SC" panose="020B0200000000000000" charset="-122"/>
+                <a:ea typeface="Noto Sans SC" panose="020B0200000000000000" charset="-122"/>
+                <a:cs typeface="Noto Sans SC" panose="020B0200000000000000" charset="-122"/>
+                <a:sym typeface="Noto Sans SC" panose="020B0200000000000000" charset="-122"/>
+              </a:rPr>
+              <a:t>Ollama</a:t>
+            </a:r>
+            <a:r>
+              <a:rPr lang="zh-CN" altLang="en-US">
+                <a:solidFill>
+                  <a:srgbClr val="9A3412"/>
+                </a:solidFill>
+                <a:latin typeface="Noto Sans SC" panose="020B0200000000000000" charset="-122"/>
+                <a:ea typeface="Noto Sans SC" panose="020B0200000000000000" charset="-122"/>
+                <a:cs typeface="Noto Sans SC" panose="020B0200000000000000" charset="-122"/>
+                <a:sym typeface="Noto Sans SC" panose="020B0200000000000000" charset="-122"/>
+              </a:rPr>
+              <a:t>本地自建模型，但是模型比较弱。</a:t>
+            </a:r>
+            <a:endParaRPr lang="en-US" sz="1400" b="0" i="0" u="none" strike="noStrike">
+              <a:solidFill>
+                <a:srgbClr val="9A3412"/>
+              </a:solidFill>
+              <a:latin typeface="Noto Sans SC" panose="020B0200000000000000" charset="-122"/>
+              <a:ea typeface="Noto Sans SC" panose="020B0200000000000000" charset="-122"/>
+              <a:cs typeface="Noto Sans SC" panose="020B0200000000000000" charset="-122"/>
+              <a:sym typeface="Noto Sans SC" panose="020B0200000000000000" charset="-122"/>
+            </a:endParaRPr>
+          </a:p>
+          <a:p>
+            <a:pPr indent="0" algn="l">
+              <a:lnSpc>
+                <a:spcPct val="125000"/>
+              </a:lnSpc>
+              <a:defRPr/>
+            </a:pPr>
+            <a:r>
+              <a:rPr lang="zh-CN" altLang="en-US" sz="1400" b="0" i="0" u="none" strike="noStrike">
+                <a:solidFill>
+                  <a:srgbClr val="9A3412"/>
+                </a:solidFill>
+                <a:latin typeface="Noto Sans SC" panose="020B0200000000000000" charset="-122"/>
+                <a:ea typeface="Noto Sans SC" panose="020B0200000000000000" charset="-122"/>
+                <a:cs typeface="Noto Sans SC" panose="020B0200000000000000" charset="-122"/>
+                <a:sym typeface="Noto Sans SC" panose="020B0200000000000000" charset="-122"/>
+              </a:rPr>
+              <a:t>最终还是</a:t>
+            </a:r>
             <a:r>
               <a:rPr lang="en-US" sz="1400" b="0" i="0" u="none" strike="noStrike">
                 <a:solidFill>
@@ -15786,9 +15845,82 @@
                 <a:cs typeface="Noto Sans SC" panose="020B0200000000000000" charset="-122"/>
                 <a:sym typeface="Noto Sans SC" panose="020B0200000000000000" charset="-122"/>
               </a:rPr>
-              <a:t>入门阶段优先选择Trae，因为它免费、模型强度高且容易上手，非常适合初学者快速建立信心。</a:t>
+              <a:t>选择</a:t>
             </a:r>
-            <a:endParaRPr lang="en-US" sz="1100"/>
+            <a:r>
+              <a:rPr lang="zh-CN" altLang="en-US" sz="1400" b="0" i="0" u="none" strike="noStrike">
+                <a:solidFill>
+                  <a:srgbClr val="9A3412"/>
+                </a:solidFill>
+                <a:latin typeface="Noto Sans SC" panose="020B0200000000000000" charset="-122"/>
+                <a:ea typeface="Noto Sans SC" panose="020B0200000000000000" charset="-122"/>
+                <a:cs typeface="Noto Sans SC" panose="020B0200000000000000" charset="-122"/>
+                <a:sym typeface="Noto Sans SC" panose="020B0200000000000000" charset="-122"/>
+              </a:rPr>
+              <a:t>了</a:t>
+            </a:r>
+            <a:r>
+              <a:rPr lang="en-US" sz="1400" b="0" i="0" u="none" strike="noStrike">
+                <a:solidFill>
+                  <a:srgbClr val="9A3412"/>
+                </a:solidFill>
+                <a:latin typeface="Noto Sans SC" panose="020B0200000000000000" charset="-122"/>
+                <a:ea typeface="Noto Sans SC" panose="020B0200000000000000" charset="-122"/>
+                <a:cs typeface="Noto Sans SC" panose="020B0200000000000000" charset="-122"/>
+                <a:sym typeface="Noto Sans SC" panose="020B0200000000000000" charset="-122"/>
+              </a:rPr>
+              <a:t>Trae</a:t>
+            </a:r>
+            <a:r>
+              <a:rPr lang="zh-CN" altLang="en-US" sz="1400" b="0" i="0" u="none" strike="noStrike">
+                <a:solidFill>
+                  <a:srgbClr val="9A3412"/>
+                </a:solidFill>
+                <a:latin typeface="Noto Sans SC" panose="020B0200000000000000" charset="-122"/>
+                <a:ea typeface="Noto Sans SC" panose="020B0200000000000000" charset="-122"/>
+                <a:cs typeface="Noto Sans SC" panose="020B0200000000000000" charset="-122"/>
+                <a:sym typeface="Noto Sans SC" panose="020B0200000000000000" charset="-122"/>
+              </a:rPr>
+              <a:t>。</a:t>
+            </a:r>
+            <a:r>
+              <a:rPr lang="en-US" sz="1400" b="0" i="0" u="none" strike="noStrike">
+                <a:solidFill>
+                  <a:srgbClr val="9A3412"/>
+                </a:solidFill>
+                <a:latin typeface="Noto Sans SC" panose="020B0200000000000000" charset="-122"/>
+                <a:ea typeface="Noto Sans SC" panose="020B0200000000000000" charset="-122"/>
+                <a:cs typeface="Noto Sans SC" panose="020B0200000000000000" charset="-122"/>
+                <a:sym typeface="Noto Sans SC" panose="020B0200000000000000" charset="-122"/>
+              </a:rPr>
+              <a:t>因为免费、模型强度高且容易上手。</a:t>
+            </a:r>
+            <a:endParaRPr lang="en-US" sz="1400" b="0" i="0" u="none" strike="noStrike">
+              <a:solidFill>
+                <a:srgbClr val="9A3412"/>
+              </a:solidFill>
+              <a:latin typeface="Noto Sans SC" panose="020B0200000000000000" charset="-122"/>
+              <a:ea typeface="Noto Sans SC" panose="020B0200000000000000" charset="-122"/>
+              <a:cs typeface="Noto Sans SC" panose="020B0200000000000000" charset="-122"/>
+              <a:sym typeface="Noto Sans SC" panose="020B0200000000000000" charset="-122"/>
+            </a:endParaRPr>
+          </a:p>
+          <a:p>
+            <a:pPr indent="0" algn="l">
+              <a:lnSpc>
+                <a:spcPct val="125000"/>
+              </a:lnSpc>
+              <a:defRPr/>
+            </a:pPr>
+            <a:endParaRPr lang="zh-CN" altLang="en-US" sz="1400" b="0" i="0" u="none" strike="noStrike">
+              <a:solidFill>
+                <a:srgbClr val="9A3412"/>
+              </a:solidFill>
+              <a:latin typeface="Noto Sans SC" panose="020B0200000000000000" charset="-122"/>
+              <a:ea typeface="Noto Sans SC" panose="020B0200000000000000" charset="-122"/>
+              <a:cs typeface="Noto Sans SC" panose="020B0200000000000000" charset="-122"/>
+              <a:sym typeface="Noto Sans SC" panose="020B0200000000000000" charset="-122"/>
+            </a:endParaRPr>
           </a:p>
         </p:txBody>
       </p:sp>

</xml_diff>